<commit_message>
Minor updates to presentation, validation log, update codegen file: Found issue with Out Of memory during validation phase
</commit_message>
<xml_diff>
--- a/Group-30/Presentation/Group30-CodeGen-Capstone-Presentation.pptx
+++ b/Group-30/Presentation/Group30-CodeGen-Capstone-Presentation.pptx
@@ -3285,7 +3285,7 @@
         <p:spPr>
           <a:xfrm>
             <a:off x="868680" y="2880360"/>
-            <a:ext cx="10332720" cy="822960"/>
+            <a:ext cx="10332720" cy="703975"/>
           </a:xfrm>
           <a:prstGeom prst="rect">
             <a:avLst/>
@@ -3304,7 +3304,7 @@
               </a:lnSpc>
             </a:pPr>
             <a:r>
-              <a:rPr sz="1900" b="0" i="1">
+              <a:rPr sz="1900" b="0" i="1" dirty="0">
                 <a:solidFill>
                   <a:srgbClr val="C7D9E2"/>
                 </a:solidFill>
@@ -3312,15 +3312,35 @@
               </a:rPr>
               <a:t>Cross-Language Code Generation with Fine-Tuned LLMs</a:t>
             </a:r>
-            <a:br/>
-            <a:r>
-              <a:rPr sz="1900" b="0" i="1">
+            <a:br>
+              <a:rPr dirty="0"/>
+            </a:br>
+            <a:r>
+              <a:rPr sz="1900" b="0" i="1" dirty="0">
                 <a:solidFill>
                   <a:srgbClr val="C7D9E2"/>
                 </a:solidFill>
                 <a:latin typeface="Calibri"/>
               </a:rPr>
-              <a:t>Natural Language → Python → C++, with Voice-Enabled Interaction</a:t>
+              <a:t>Natural Language → Python </a:t>
+            </a:r>
+            <a:r>
+              <a:rPr lang="en-US" sz="1900" b="0" i="1" dirty="0">
+                <a:solidFill>
+                  <a:srgbClr val="C7D9E2"/>
+                </a:solidFill>
+                <a:latin typeface="Calibri"/>
+              </a:rPr>
+              <a:t> or C++, Python </a:t>
+            </a:r>
+            <a:r>
+              <a:rPr sz="1900" b="0" i="1" dirty="0">
+                <a:solidFill>
+                  <a:srgbClr val="C7D9E2"/>
+                </a:solidFill>
+                <a:latin typeface="Calibri"/>
+              </a:rPr>
+              <a:t>→ C++, with Voice-Enabled Interaction</a:t>
             </a:r>
           </a:p>
         </p:txBody>
@@ -4487,13 +4507,22 @@
               </a:lnSpc>
             </a:pPr>
             <a:r>
-              <a:rPr sz="1200" b="0" i="1">
+              <a:rPr sz="1200" b="0" i="1" dirty="0" err="1">
                 <a:solidFill>
                   <a:srgbClr val="555F6E"/>
                 </a:solidFill>
                 <a:latin typeface="Calibri"/>
               </a:rPr>
-              <a:t>CodeGen — IIIT Hyderabad Capstone Project, Group 30</a:t>
+              <a:t>CodeGen</a:t>
+            </a:r>
+            <a:r>
+              <a:rPr sz="1200" b="0" i="1" dirty="0">
+                <a:solidFill>
+                  <a:srgbClr val="555F6E"/>
+                </a:solidFill>
+                <a:latin typeface="Calibri"/>
+              </a:rPr>
+              <a:t> — IIIT Hyderabad Capstone Project, Group 30</a:t>
             </a:r>
           </a:p>
         </p:txBody>
@@ -4825,7 +4854,7 @@
         <p:spPr>
           <a:xfrm>
             <a:off x="502920" y="1627632"/>
-            <a:ext cx="11155680" cy="777240"/>
+            <a:ext cx="11155680" cy="731290"/>
           </a:xfrm>
           <a:prstGeom prst="rect">
             <a:avLst/>
@@ -4844,13 +4873,31 @@
               </a:lnSpc>
             </a:pPr>
             <a:r>
-              <a:rPr sz="1350" b="0" i="0">
+              <a:rPr sz="1350" b="0" i="0" dirty="0">
                 <a:solidFill>
                   <a:srgbClr val="1A1F2B"/>
                 </a:solidFill>
                 <a:latin typeface="Calibri"/>
               </a:rPr>
-              <a:t>LLMs increasingly understand and synthesize code, not just natural language. This project applies and fine-tunes an LLM to translate between natural language and two programming languages (Python, C++) — demonstrating a path to extend code-generation support to languages an LLM was not originally trained on.</a:t>
+              <a:t>LLMs increasingly understand and synthesize code, not just natural language. This project applies and fine-tunes an LLM to translate between natural language and two programming languages (Python, C++) </a:t>
+            </a:r>
+            <a:r>
+              <a:rPr lang="en-US" sz="1350" b="0" i="0" dirty="0">
+                <a:solidFill>
+                  <a:srgbClr val="1A1F2B"/>
+                </a:solidFill>
+                <a:latin typeface="Calibri"/>
+              </a:rPr>
+              <a:t>and Python to C++ translation</a:t>
+            </a:r>
+            <a:r>
+              <a:rPr sz="1350" b="0" i="0" dirty="0">
+                <a:solidFill>
+                  <a:srgbClr val="1A1F2B"/>
+                </a:solidFill>
+                <a:latin typeface="Calibri"/>
+              </a:rPr>
+              <a:t>— demonstrating a path to extend code-generation support to languages an LLM was not originally trained on.</a:t>
             </a:r>
           </a:p>
         </p:txBody>

</xml_diff>

<commit_message>
Add final presentation draft v2
</commit_message>
<xml_diff>
--- a/Group-30/Presentation/Group30-CodeGen-Capstone-Presentation.pptx
+++ b/Group-30/Presentation/Group30-CodeGen-Capstone-Presentation.pptx
@@ -312,7 +312,7 @@
           <a:p>
             <a:fld id="{5BCAD085-E8A6-8845-BD4E-CB4CCA059FC4}" type="datetimeFigureOut">
               <a:rPr lang="en-US" smtClean="0"/>
-              <a:t>7/5/2026</a:t>
+              <a:t>8/1/26</a:t>
             </a:fld>
             <a:endParaRPr lang="en-US"/>
           </a:p>
@@ -480,7 +480,7 @@
           <a:p>
             <a:fld id="{5BCAD085-E8A6-8845-BD4E-CB4CCA059FC4}" type="datetimeFigureOut">
               <a:rPr lang="en-US" smtClean="0"/>
-              <a:t>7/5/2026</a:t>
+              <a:t>8/1/26</a:t>
             </a:fld>
             <a:endParaRPr lang="en-US"/>
           </a:p>
@@ -658,7 +658,7 @@
           <a:p>
             <a:fld id="{5BCAD085-E8A6-8845-BD4E-CB4CCA059FC4}" type="datetimeFigureOut">
               <a:rPr lang="en-US" smtClean="0"/>
-              <a:t>7/5/2026</a:t>
+              <a:t>8/1/26</a:t>
             </a:fld>
             <a:endParaRPr lang="en-US"/>
           </a:p>
@@ -826,7 +826,7 @@
           <a:p>
             <a:fld id="{5BCAD085-E8A6-8845-BD4E-CB4CCA059FC4}" type="datetimeFigureOut">
               <a:rPr lang="en-US" smtClean="0"/>
-              <a:t>7/5/2026</a:t>
+              <a:t>8/1/26</a:t>
             </a:fld>
             <a:endParaRPr lang="en-US"/>
           </a:p>
@@ -1071,7 +1071,7 @@
           <a:p>
             <a:fld id="{5BCAD085-E8A6-8845-BD4E-CB4CCA059FC4}" type="datetimeFigureOut">
               <a:rPr lang="en-US" smtClean="0"/>
-              <a:t>7/5/2026</a:t>
+              <a:t>8/1/26</a:t>
             </a:fld>
             <a:endParaRPr lang="en-US"/>
           </a:p>
@@ -1356,7 +1356,7 @@
           <a:p>
             <a:fld id="{5BCAD085-E8A6-8845-BD4E-CB4CCA059FC4}" type="datetimeFigureOut">
               <a:rPr lang="en-US" smtClean="0"/>
-              <a:t>7/5/2026</a:t>
+              <a:t>8/1/26</a:t>
             </a:fld>
             <a:endParaRPr lang="en-US"/>
           </a:p>
@@ -1775,7 +1775,7 @@
           <a:p>
             <a:fld id="{5BCAD085-E8A6-8845-BD4E-CB4CCA059FC4}" type="datetimeFigureOut">
               <a:rPr lang="en-US" smtClean="0"/>
-              <a:t>7/5/2026</a:t>
+              <a:t>8/1/26</a:t>
             </a:fld>
             <a:endParaRPr lang="en-US"/>
           </a:p>
@@ -1892,7 +1892,7 @@
           <a:p>
             <a:fld id="{5BCAD085-E8A6-8845-BD4E-CB4CCA059FC4}" type="datetimeFigureOut">
               <a:rPr lang="en-US" smtClean="0"/>
-              <a:t>7/5/2026</a:t>
+              <a:t>8/1/26</a:t>
             </a:fld>
             <a:endParaRPr lang="en-US"/>
           </a:p>
@@ -1987,7 +1987,7 @@
           <a:p>
             <a:fld id="{5BCAD085-E8A6-8845-BD4E-CB4CCA059FC4}" type="datetimeFigureOut">
               <a:rPr lang="en-US" smtClean="0"/>
-              <a:t>7/5/2026</a:t>
+              <a:t>8/1/26</a:t>
             </a:fld>
             <a:endParaRPr lang="en-US"/>
           </a:p>
@@ -2262,7 +2262,7 @@
           <a:p>
             <a:fld id="{5BCAD085-E8A6-8845-BD4E-CB4CCA059FC4}" type="datetimeFigureOut">
               <a:rPr lang="en-US" smtClean="0"/>
-              <a:t>7/5/2026</a:t>
+              <a:t>8/1/26</a:t>
             </a:fld>
             <a:endParaRPr lang="en-US"/>
           </a:p>
@@ -2514,7 +2514,7 @@
           <a:p>
             <a:fld id="{5BCAD085-E8A6-8845-BD4E-CB4CCA059FC4}" type="datetimeFigureOut">
               <a:rPr lang="en-US" smtClean="0"/>
-              <a:t>7/5/2026</a:t>
+              <a:t>8/1/26</a:t>
             </a:fld>
             <a:endParaRPr lang="en-US"/>
           </a:p>
@@ -2725,7 +2725,7 @@
           <a:p>
             <a:fld id="{5BCAD085-E8A6-8845-BD4E-CB4CCA059FC4}" type="datetimeFigureOut">
               <a:rPr lang="en-US" smtClean="0"/>
-              <a:t>7/5/2026</a:t>
+              <a:t>8/1/26</a:t>
             </a:fld>
             <a:endParaRPr lang="en-US"/>
           </a:p>
@@ -3438,7 +3438,7 @@
         <p:spPr>
           <a:xfrm>
             <a:off x="868680" y="4572000"/>
-            <a:ext cx="5120640" cy="1463040"/>
+            <a:ext cx="5120640" cy="1359090"/>
           </a:xfrm>
           <a:prstGeom prst="rect">
             <a:avLst/>
@@ -3460,7 +3460,7 @@
               </a:spcAft>
             </a:pPr>
             <a:r>
-              <a:rPr sz="1600" b="1">
+              <a:rPr sz="1600" b="1" dirty="0">
                 <a:solidFill>
                   <a:srgbClr val="1F7A8C"/>
                 </a:solidFill>
@@ -3469,7 +3469,7 @@
               <a:t>▪  </a:t>
             </a:r>
             <a:r>
-              <a:rPr sz="1600" b="0" i="0">
+              <a:rPr sz="1600" b="0" i="0" dirty="0">
                 <a:solidFill>
                   <a:srgbClr val="FFFFFF"/>
                 </a:solidFill>
@@ -3488,7 +3488,7 @@
               </a:spcAft>
             </a:pPr>
             <a:r>
-              <a:rPr sz="1600" b="1">
+              <a:rPr sz="1600" b="1" dirty="0">
                 <a:solidFill>
                   <a:srgbClr val="1F7A8C"/>
                 </a:solidFill>
@@ -3497,7 +3497,7 @@
               <a:t>▪  </a:t>
             </a:r>
             <a:r>
-              <a:rPr sz="1600" b="0" i="0">
+              <a:rPr sz="1600" b="0" i="0" dirty="0">
                 <a:solidFill>
                   <a:srgbClr val="FFFFFF"/>
                 </a:solidFill>
@@ -3531,7 +3531,34 @@
                 </a:solidFill>
                 <a:latin typeface="Calibri"/>
               </a:rPr>
-              <a:t>Kihim Lohitha</a:t>
+              <a:t>Ki</a:t>
+            </a:r>
+            <a:r>
+              <a:rPr lang="en-US" sz="1600" b="0" i="0">
+                <a:solidFill>
+                  <a:srgbClr val="FFFFFF"/>
+                </a:solidFill>
+                <a:latin typeface="Calibri"/>
+              </a:rPr>
+              <a:t>l</a:t>
+            </a:r>
+            <a:r>
+              <a:rPr sz="1600" b="0" i="0">
+                <a:solidFill>
+                  <a:srgbClr val="FFFFFF"/>
+                </a:solidFill>
+                <a:latin typeface="Calibri"/>
+              </a:rPr>
+              <a:t>im </a:t>
+            </a:r>
+            <a:r>
+              <a:rPr sz="1600" b="0" i="0" dirty="0">
+                <a:solidFill>
+                  <a:srgbClr val="FFFFFF"/>
+                </a:solidFill>
+                <a:latin typeface="Calibri"/>
+              </a:rPr>
+              <a:t>Lohitha</a:t>
             </a:r>
           </a:p>
           <a:p>
@@ -3544,7 +3571,7 @@
               </a:spcAft>
             </a:pPr>
             <a:r>
-              <a:rPr sz="1600" b="1">
+              <a:rPr sz="1600" b="1" dirty="0">
                 <a:solidFill>
                   <a:srgbClr val="1F7A8C"/>
                 </a:solidFill>
@@ -3553,7 +3580,7 @@
               <a:t>▪  </a:t>
             </a:r>
             <a:r>
-              <a:rPr sz="1600" b="0" i="0">
+              <a:rPr sz="1600" b="0" i="0" dirty="0">
                 <a:solidFill>
                   <a:srgbClr val="FFFFFF"/>
                 </a:solidFill>

</xml_diff>